<commit_message>
Vecka 44: figurer, texträttelser och filmen IT-nätet ombord (före granskning)
Co-Authored-By: Claude Opus 5.5 <noreply@anthropic.com>
Claude-Session: https://claude.ai/code/session_011V9KjBb53XrDm23Dw58SH3
</commit_message>
<xml_diff>
--- a/sjoskolan/vecka-44/aktuell/v44_01_Lagspanningssystem_elev.pptx
+++ b/sjoskolan/vecka-44/aktuell/v44_01_Lagspanningssystem_elev.pptx
@@ -4566,7 +4566,51 @@
                 <a:ea typeface="Calibri"/>
                 <a:cs typeface="Calibri"/>
               </a:rPr>
-              <a:t>Ifel ≈ U/Zfel</a:t>
+              <a:t>I</a:t>
+            </a:r>
+            <a:r>
+              <a:rPr sz="2400" b="1" baseline="-25000">
+                <a:solidFill>
+                  <a:srgbClr val="064F91"/>
+                </a:solidFill>
+                <a:latin typeface="Calibri"/>
+                <a:ea typeface="Calibri"/>
+                <a:cs typeface="Calibri"/>
+              </a:rPr>
+              <a:t>fel</a:t>
+            </a:r>
+            <a:r>
+              <a:rPr sz="2400" b="1">
+                <a:solidFill>
+                  <a:srgbClr val="064F91"/>
+                </a:solidFill>
+                <a:latin typeface="Calibri"/>
+                <a:ea typeface="Calibri"/>
+                <a:cs typeface="Calibri"/>
+              </a:rPr>
+              <a:t> ≈ U/</a:t>
+            </a:r>
+            <a:r>
+              <a:rPr sz="2400" b="1">
+                <a:solidFill>
+                  <a:srgbClr val="064F91"/>
+                </a:solidFill>
+                <a:latin typeface="Calibri"/>
+                <a:ea typeface="Calibri"/>
+                <a:cs typeface="Calibri"/>
+              </a:rPr>
+              <a:t>Z</a:t>
+            </a:r>
+            <a:r>
+              <a:rPr sz="2400" b="1" baseline="-25000">
+                <a:solidFill>
+                  <a:srgbClr val="064F91"/>
+                </a:solidFill>
+                <a:latin typeface="Calibri"/>
+                <a:ea typeface="Calibri"/>
+                <a:cs typeface="Calibri"/>
+              </a:rPr>
+              <a:t>fel</a:t>
             </a:r>
           </a:p>
         </p:txBody>
@@ -8172,7 +8216,7 @@
         <p:spPr>
           <a:xfrm xmlns:a="http://schemas.openxmlformats.org/drawingml/2006/main">
             <a:off x="762000" y="1619250"/>
-            <a:ext cx="7620000" cy="1466850"/>
+            <a:ext cx="3977639" cy="1466850"/>
           </a:xfrm>
           <a:prstGeom xmlns:a="http://schemas.openxmlformats.org/drawingml/2006/main" prst="rect">
             <a:avLst/>
@@ -8200,7 +8244,7 @@
               </a:defRPr>
             </a:pPr>
             <a:r>
-              <a:rPr sz="2400" b="0">
+              <a:rPr sz="1750" b="0">
                 <a:solidFill>
                   <a:srgbClr val="111111"/>
                 </a:solidFill>
@@ -8224,7 +8268,7 @@
               </a:defRPr>
             </a:pPr>
             <a:r>
-              <a:rPr sz="2400" b="0">
+              <a:rPr sz="1750" b="0">
                 <a:solidFill>
                   <a:srgbClr val="111111"/>
                 </a:solidFill>
@@ -8254,7 +8298,7 @@
         <p:spPr>
           <a:xfrm xmlns:a="http://schemas.openxmlformats.org/drawingml/2006/main">
             <a:off x="762000" y="3200400"/>
-            <a:ext cx="7620000" cy="838200"/>
+            <a:ext cx="3977639" cy="838200"/>
           </a:xfrm>
           <a:prstGeom xmlns:a="http://schemas.openxmlformats.org/drawingml/2006/main" prst="rect">
             <a:avLst/>
@@ -8282,7 +8326,7 @@
               </a:defRPr>
             </a:pPr>
             <a:r>
-              <a:rPr sz="2925" b="1">
+              <a:rPr sz="2300" b="1">
                 <a:solidFill>
                   <a:srgbClr val="064F91"/>
                 </a:solidFill>
@@ -8312,7 +8356,7 @@
         <p:spPr>
           <a:xfrm xmlns:a="http://schemas.openxmlformats.org/drawingml/2006/main">
             <a:off x="762000" y="4429125"/>
-            <a:ext cx="7620000" cy="1352550"/>
+            <a:ext cx="3977639" cy="1352550"/>
           </a:xfrm>
           <a:prstGeom xmlns:a="http://schemas.openxmlformats.org/drawingml/2006/main" prst="rect">
             <a:avLst/>
@@ -8340,7 +8384,7 @@
               </a:defRPr>
             </a:pPr>
             <a:r>
-              <a:rPr sz="2250" b="0">
+              <a:rPr sz="1800" b="0">
                 <a:solidFill>
                   <a:srgbClr val="111111"/>
                 </a:solidFill>
@@ -8364,7 +8408,7 @@
               </a:defRPr>
             </a:pPr>
             <a:r>
-              <a:rPr sz="2250" b="0">
+              <a:rPr sz="1800" b="0">
                 <a:solidFill>
                   <a:srgbClr val="111111"/>
                 </a:solidFill>
@@ -8435,6 +8479,30 @@
           </a:p>
         </p:txBody>
       </p:sp>
+      <p:pic xmlns:a="http://schemas.openxmlformats.org/drawingml/2006/main" xmlns:r="http://schemas.openxmlformats.org/officeDocument/2006/relationships">
+        <p:nvPicPr>
+          <p:cNvPr id="9" name="Figur: IT-system ombord: källan isolerad från s" descr="IT-system ombord: källan isolerad från skrovet, isolationsvakt mellan systemet och skrovet; första jordfelet ger liten ström och larm"/>
+          <p:cNvPicPr>
+            <a:picLocks noChangeAspect="1"/>
+          </p:cNvPicPr>
+          <p:nvPr/>
+        </p:nvPicPr>
+        <p:blipFill>
+          <a:blip r:embed="rId3"/>
+          <a:stretch>
+            <a:fillRect/>
+          </a:stretch>
+        </p:blipFill>
+        <p:spPr>
+          <a:xfrm>
+            <a:off x="4892040" y="1645920"/>
+            <a:ext cx="3886200" cy="3252383"/>
+          </a:xfrm>
+          <a:prstGeom prst="rect">
+            <a:avLst/>
+          </a:prstGeom>
+        </p:spPr>
+      </p:pic>
     </p:spTree>
     <p:extLst>
       <p:ext uri="{BB962C8B-B14F-4D97-AF65-F5344CB8AC3E}">
@@ -8556,7 +8624,7 @@
         <p:spPr>
           <a:xfrm xmlns:a="http://schemas.openxmlformats.org/drawingml/2006/main">
             <a:off x="762000" y="1619250"/>
-            <a:ext cx="7620000" cy="1466850"/>
+            <a:ext cx="3977639" cy="1466850"/>
           </a:xfrm>
           <a:prstGeom xmlns:a="http://schemas.openxmlformats.org/drawingml/2006/main" prst="rect">
             <a:avLst/>
@@ -8584,7 +8652,7 @@
               </a:defRPr>
             </a:pPr>
             <a:r>
-              <a:rPr sz="2400" b="0">
+              <a:rPr sz="1800" b="0">
                 <a:solidFill>
                   <a:srgbClr val="111111"/>
                 </a:solidFill>
@@ -8608,7 +8676,7 @@
               </a:defRPr>
             </a:pPr>
             <a:r>
-              <a:rPr sz="2400" b="0">
+              <a:rPr sz="1800" b="0">
                 <a:solidFill>
                   <a:srgbClr val="111111"/>
                 </a:solidFill>
@@ -8638,7 +8706,7 @@
         <p:spPr>
           <a:xfrm xmlns:a="http://schemas.openxmlformats.org/drawingml/2006/main">
             <a:off x="762000" y="3200400"/>
-            <a:ext cx="7620000" cy="838200"/>
+            <a:ext cx="3977639" cy="838200"/>
           </a:xfrm>
           <a:prstGeom xmlns:a="http://schemas.openxmlformats.org/drawingml/2006/main" prst="rect">
             <a:avLst/>
@@ -8666,7 +8734,7 @@
               </a:defRPr>
             </a:pPr>
             <a:r>
-              <a:rPr sz="2925" b="1">
+              <a:rPr sz="2650" b="1">
                 <a:solidFill>
                   <a:srgbClr val="064F91"/>
                 </a:solidFill>
@@ -8696,7 +8764,7 @@
         <p:spPr>
           <a:xfrm xmlns:a="http://schemas.openxmlformats.org/drawingml/2006/main">
             <a:off x="762000" y="4429125"/>
-            <a:ext cx="7620000" cy="1352550"/>
+            <a:ext cx="3977639" cy="1352550"/>
           </a:xfrm>
           <a:prstGeom xmlns:a="http://schemas.openxmlformats.org/drawingml/2006/main" prst="rect">
             <a:avLst/>
@@ -8724,7 +8792,7 @@
               </a:defRPr>
             </a:pPr>
             <a:r>
-              <a:rPr sz="2250" b="0">
+              <a:rPr sz="1800" b="0">
                 <a:solidFill>
                   <a:srgbClr val="111111"/>
                 </a:solidFill>
@@ -8748,7 +8816,7 @@
               </a:defRPr>
             </a:pPr>
             <a:r>
-              <a:rPr sz="2250" b="0">
+              <a:rPr sz="1800" b="0">
                 <a:solidFill>
                   <a:srgbClr val="111111"/>
                 </a:solidFill>
@@ -8819,6 +8887,30 @@
           </a:p>
         </p:txBody>
       </p:sp>
+      <p:pic xmlns:a="http://schemas.openxmlformats.org/drawingml/2006/main" xmlns:r="http://schemas.openxmlformats.org/officeDocument/2006/relationships">
+        <p:nvPicPr>
+          <p:cNvPr id="9" name="Figur: IT-system med ett andra jordfel på en an" descr="IT-system med ett andra jordfel på en annan fas: kortslutning mellan L1 och L2 via skrovet"/>
+          <p:cNvPicPr>
+            <a:picLocks noChangeAspect="1"/>
+          </p:cNvPicPr>
+          <p:nvPr/>
+        </p:nvPicPr>
+        <p:blipFill>
+          <a:blip r:embed="rId3"/>
+          <a:stretch>
+            <a:fillRect/>
+          </a:stretch>
+        </p:blipFill>
+        <p:spPr>
+          <a:xfrm>
+            <a:off x="4892040" y="1645920"/>
+            <a:ext cx="3886200" cy="3252383"/>
+          </a:xfrm>
+          <a:prstGeom prst="rect">
+            <a:avLst/>
+          </a:prstGeom>
+        </p:spPr>
+      </p:pic>
     </p:spTree>
     <p:extLst>
       <p:ext uri="{BB962C8B-B14F-4D97-AF65-F5344CB8AC3E}">
@@ -9058,7 +9150,29 @@
                 <a:ea typeface="Calibri"/>
                 <a:cs typeface="Calibri"/>
               </a:rPr>
-              <a:t>Iₖ ≈ U₀/Zs</a:t>
+              <a:t>Iₖ ≈ U₀/</a:t>
+            </a:r>
+            <a:r>
+              <a:rPr sz="2925" b="1">
+                <a:solidFill>
+                  <a:srgbClr val="064F91"/>
+                </a:solidFill>
+                <a:latin typeface="Calibri"/>
+                <a:ea typeface="Calibri"/>
+                <a:cs typeface="Calibri"/>
+              </a:rPr>
+              <a:t>Z</a:t>
+            </a:r>
+            <a:r>
+              <a:rPr sz="2925" b="1" baseline="-25000">
+                <a:solidFill>
+                  <a:srgbClr val="064F91"/>
+                </a:solidFill>
+                <a:latin typeface="Calibri"/>
+                <a:ea typeface="Calibri"/>
+                <a:cs typeface="Calibri"/>
+              </a:rPr>
+              <a:t>s</a:t>
             </a:r>
           </a:p>
         </p:txBody>
@@ -9116,7 +9230,40 @@
                 <a:ea typeface="Calibri"/>
                 <a:cs typeface="Calibri"/>
               </a:rPr>
-              <a:t>230 V och Zs = 0,46 Ω ger cirka 500 A.</a:t>
+              <a:t>230 V och </a:t>
+            </a:r>
+            <a:r>
+              <a:rPr sz="2250" b="0">
+                <a:solidFill>
+                  <a:srgbClr val="111111"/>
+                </a:solidFill>
+                <a:latin typeface="Calibri"/>
+                <a:ea typeface="Calibri"/>
+                <a:cs typeface="Calibri"/>
+              </a:rPr>
+              <a:t>Z</a:t>
+            </a:r>
+            <a:r>
+              <a:rPr sz="2250" b="0" baseline="-25000">
+                <a:solidFill>
+                  <a:srgbClr val="111111"/>
+                </a:solidFill>
+                <a:latin typeface="Calibri"/>
+                <a:ea typeface="Calibri"/>
+                <a:cs typeface="Calibri"/>
+              </a:rPr>
+              <a:t>s</a:t>
+            </a:r>
+            <a:r>
+              <a:rPr sz="2250" b="0">
+                <a:solidFill>
+                  <a:srgbClr val="111111"/>
+                </a:solidFill>
+                <a:latin typeface="Calibri"/>
+                <a:ea typeface="Calibri"/>
+                <a:cs typeface="Calibri"/>
+              </a:rPr>
+              <a:t> = 0,32 Ω ger cirka 720 A.</a:t>
             </a:r>
           </a:p>
           <a:p xmlns:a="http://schemas.openxmlformats.org/drawingml/2006/main">
@@ -9323,7 +9470,7 @@
         <p:spPr>
           <a:xfrm xmlns:a="http://schemas.openxmlformats.org/drawingml/2006/main">
             <a:off x="762000" y="1571625"/>
-            <a:ext cx="7620000" cy="990600"/>
+            <a:ext cx="3977639" cy="990600"/>
           </a:xfrm>
           <a:prstGeom xmlns:a="http://schemas.openxmlformats.org/drawingml/2006/main" prst="rect">
             <a:avLst/>
@@ -9350,15 +9497,48 @@
               </a:defRPr>
             </a:pPr>
             <a:r>
-              <a:rPr sz="2175" b="0">
-                <a:solidFill>
-                  <a:srgbClr val="111111"/>
-                </a:solidFill>
-                <a:latin typeface="Calibri"/>
-                <a:ea typeface="Calibri"/>
-                <a:cs typeface="Calibri"/>
-              </a:rPr>
-              <a:t>En förenklad felströmsslinga har U₀ = 230 V och Zs = 0,575 Ω.</a:t>
+              <a:rPr sz="2100" b="0">
+                <a:solidFill>
+                  <a:srgbClr val="111111"/>
+                </a:solidFill>
+                <a:latin typeface="Calibri"/>
+                <a:ea typeface="Calibri"/>
+                <a:cs typeface="Calibri"/>
+              </a:rPr>
+              <a:t>En förenklad felströmsslinga har U₀ = 230 V och </a:t>
+            </a:r>
+            <a:r>
+              <a:rPr sz="2100" b="0">
+                <a:solidFill>
+                  <a:srgbClr val="111111"/>
+                </a:solidFill>
+                <a:latin typeface="Calibri"/>
+                <a:ea typeface="Calibri"/>
+                <a:cs typeface="Calibri"/>
+              </a:rPr>
+              <a:t>Z</a:t>
+            </a:r>
+            <a:r>
+              <a:rPr sz="2100" b="0" baseline="-25000">
+                <a:solidFill>
+                  <a:srgbClr val="111111"/>
+                </a:solidFill>
+                <a:latin typeface="Calibri"/>
+                <a:ea typeface="Calibri"/>
+                <a:cs typeface="Calibri"/>
+              </a:rPr>
+              <a:t>s</a:t>
+            </a:r>
+            <a:r>
+              <a:rPr sz="2100" b="0">
+                <a:solidFill>
+                  <a:srgbClr val="111111"/>
+                </a:solidFill>
+                <a:latin typeface="Calibri"/>
+                <a:ea typeface="Calibri"/>
+                <a:cs typeface="Calibri"/>
+              </a:rPr>
+              <a:t> = 0,575 Ω.</a:t>
             </a:r>
           </a:p>
         </p:txBody>
@@ -9380,7 +9560,7 @@
         <p:spPr>
           <a:xfrm xmlns:a="http://schemas.openxmlformats.org/drawingml/2006/main">
             <a:off x="762000" y="2705100"/>
-            <a:ext cx="7620000" cy="790575"/>
+            <a:ext cx="3977639" cy="790575"/>
           </a:xfrm>
           <a:prstGeom xmlns:a="http://schemas.openxmlformats.org/drawingml/2006/main" prst="rect">
             <a:avLst/>
@@ -9415,7 +9595,29 @@
                 <a:ea typeface="Calibri"/>
                 <a:cs typeface="Calibri"/>
               </a:rPr>
-              <a:t>Iₖ ≈ U₀/Zs</a:t>
+              <a:t>Iₖ ≈ U₀/</a:t>
+            </a:r>
+            <a:r>
+              <a:rPr sz="2325" b="1">
+                <a:solidFill>
+                  <a:srgbClr val="064F91"/>
+                </a:solidFill>
+                <a:latin typeface="Calibri"/>
+                <a:ea typeface="Calibri"/>
+                <a:cs typeface="Calibri"/>
+              </a:rPr>
+              <a:t>Z</a:t>
+            </a:r>
+            <a:r>
+              <a:rPr sz="2325" b="1" baseline="-25000">
+                <a:solidFill>
+                  <a:srgbClr val="064F91"/>
+                </a:solidFill>
+                <a:latin typeface="Calibri"/>
+                <a:ea typeface="Calibri"/>
+                <a:cs typeface="Calibri"/>
+              </a:rPr>
+              <a:t>s</a:t>
             </a:r>
           </a:p>
         </p:txBody>
@@ -9437,7 +9639,7 @@
         <p:spPr>
           <a:xfrm xmlns:a="http://schemas.openxmlformats.org/drawingml/2006/main">
             <a:off x="762000" y="3657600"/>
-            <a:ext cx="7620000" cy="1524000"/>
+            <a:ext cx="3977639" cy="1524000"/>
           </a:xfrm>
           <a:prstGeom xmlns:a="http://schemas.openxmlformats.org/drawingml/2006/main" prst="rect">
             <a:avLst/>
@@ -9464,15 +9666,15 @@
               </a:defRPr>
             </a:pPr>
             <a:r>
-              <a:rPr sz="2063" b="0">
-                <a:solidFill>
-                  <a:srgbClr val="111111"/>
-                </a:solidFill>
-                <a:latin typeface="Calibri"/>
-                <a:ea typeface="Calibri"/>
-                <a:cs typeface="Calibri"/>
-              </a:rPr>
-              <a:t>1. Iₖ ≈ 230/0,575 = 400 A.</a:t>
+              <a:rPr sz="1800" b="0">
+                <a:solidFill>
+                  <a:srgbClr val="111111"/>
+                </a:solidFill>
+                <a:latin typeface="Calibri"/>
+                <a:ea typeface="Calibri"/>
+                <a:cs typeface="Calibri"/>
+              </a:rPr>
+              <a:t>1. Iₖ ≈ 230/0,575 = 400 A.</a:t>
             </a:r>
           </a:p>
           <a:p xmlns:a="http://schemas.openxmlformats.org/drawingml/2006/main">
@@ -9487,15 +9689,48 @@
               </a:defRPr>
             </a:pPr>
             <a:r>
-              <a:rPr sz="2063" b="0">
-                <a:solidFill>
-                  <a:srgbClr val="111111"/>
-                </a:solidFill>
-                <a:latin typeface="Calibri"/>
-                <a:ea typeface="Calibri"/>
-                <a:cs typeface="Calibri"/>
-              </a:rPr>
-              <a:t>2. Om Zs fördubblas till 1,15 Ω blir Iₖ ≈ 230/1,15 = 200 A.</a:t>
+              <a:rPr sz="1800" b="0">
+                <a:solidFill>
+                  <a:srgbClr val="111111"/>
+                </a:solidFill>
+                <a:latin typeface="Calibri"/>
+                <a:ea typeface="Calibri"/>
+                <a:cs typeface="Calibri"/>
+              </a:rPr>
+              <a:t>2. Om </a:t>
+            </a:r>
+            <a:r>
+              <a:rPr sz="1800" b="0">
+                <a:solidFill>
+                  <a:srgbClr val="111111"/>
+                </a:solidFill>
+                <a:latin typeface="Calibri"/>
+                <a:ea typeface="Calibri"/>
+                <a:cs typeface="Calibri"/>
+              </a:rPr>
+              <a:t>Z</a:t>
+            </a:r>
+            <a:r>
+              <a:rPr sz="1800" b="0" baseline="-25000">
+                <a:solidFill>
+                  <a:srgbClr val="111111"/>
+                </a:solidFill>
+                <a:latin typeface="Calibri"/>
+                <a:ea typeface="Calibri"/>
+                <a:cs typeface="Calibri"/>
+              </a:rPr>
+              <a:t>s</a:t>
+            </a:r>
+            <a:r>
+              <a:rPr sz="1800" b="0">
+                <a:solidFill>
+                  <a:srgbClr val="111111"/>
+                </a:solidFill>
+                <a:latin typeface="Calibri"/>
+                <a:ea typeface="Calibri"/>
+                <a:cs typeface="Calibri"/>
+              </a:rPr>
+              <a:t> fördubblas till 1,15 Ω blir Iₖ ≈ 230/1,15 = 200 A.</a:t>
             </a:r>
           </a:p>
           <a:p xmlns:a="http://schemas.openxmlformats.org/drawingml/2006/main">
@@ -9510,7 +9745,7 @@
               </a:defRPr>
             </a:pPr>
             <a:r>
-              <a:rPr sz="2063" b="0">
+              <a:rPr sz="1800" b="0">
                 <a:solidFill>
                   <a:srgbClr val="111111"/>
                 </a:solidFill>
@@ -9540,7 +9775,7 @@
         <p:spPr>
           <a:xfrm xmlns:a="http://schemas.openxmlformats.org/drawingml/2006/main">
             <a:off x="762000" y="5372100"/>
-            <a:ext cx="7620000" cy="685800"/>
+            <a:ext cx="3977639" cy="685800"/>
           </a:xfrm>
           <a:prstGeom xmlns:a="http://schemas.openxmlformats.org/drawingml/2006/main" prst="rect">
             <a:avLst/>
@@ -9567,15 +9802,48 @@
               </a:defRPr>
             </a:pPr>
             <a:r>
-              <a:rPr sz="1913" b="0">
-                <a:solidFill>
-                  <a:srgbClr val="111111"/>
-                </a:solidFill>
-                <a:latin typeface="Calibri"/>
-                <a:ea typeface="Calibri"/>
-                <a:cs typeface="Calibri"/>
-              </a:rPr>
-              <a:t>Utlösningstid kan inte bestämmas utan skyddsdata. Modellen visar hur högre Zs minskar felströmmen.</a:t>
+              <a:rPr sz="1550" b="0">
+                <a:solidFill>
+                  <a:srgbClr val="111111"/>
+                </a:solidFill>
+                <a:latin typeface="Calibri"/>
+                <a:ea typeface="Calibri"/>
+                <a:cs typeface="Calibri"/>
+              </a:rPr>
+              <a:t>Utlösningstid kan inte bestämmas utan skyddsdata. Modellen visar hur högre </a:t>
+            </a:r>
+            <a:r>
+              <a:rPr sz="1550" b="0">
+                <a:solidFill>
+                  <a:srgbClr val="111111"/>
+                </a:solidFill>
+                <a:latin typeface="Calibri"/>
+                <a:ea typeface="Calibri"/>
+                <a:cs typeface="Calibri"/>
+              </a:rPr>
+              <a:t>Z</a:t>
+            </a:r>
+            <a:r>
+              <a:rPr sz="1550" b="0" baseline="-25000">
+                <a:solidFill>
+                  <a:srgbClr val="111111"/>
+                </a:solidFill>
+                <a:latin typeface="Calibri"/>
+                <a:ea typeface="Calibri"/>
+                <a:cs typeface="Calibri"/>
+              </a:rPr>
+              <a:t>s</a:t>
+            </a:r>
+            <a:r>
+              <a:rPr sz="1550" b="0">
+                <a:solidFill>
+                  <a:srgbClr val="111111"/>
+                </a:solidFill>
+                <a:latin typeface="Calibri"/>
+                <a:ea typeface="Calibri"/>
+                <a:cs typeface="Calibri"/>
+              </a:rPr>
+              <a:t> minskar felströmmen.</a:t>
             </a:r>
           </a:p>
         </p:txBody>
@@ -9637,6 +9905,30 @@
           </a:p>
         </p:txBody>
       </p:sp>
+      <p:pic xmlns:a="http://schemas.openxmlformats.org/drawingml/2006/main" xmlns:r="http://schemas.openxmlformats.org/officeDocument/2006/relationships">
+        <p:nvPicPr>
+          <p:cNvPr id="16" name="Figur: Felström som funktion av slingimpedans: " descr="Felström som funktion av slingimpedans: 0,575 ohm ger 400 A och 1,15 ohm ger 200 A"/>
+          <p:cNvPicPr>
+            <a:picLocks noChangeAspect="1"/>
+          </p:cNvPicPr>
+          <p:nvPr/>
+        </p:nvPicPr>
+        <p:blipFill>
+          <a:blip r:embed="rId3"/>
+          <a:stretch>
+            <a:fillRect/>
+          </a:stretch>
+        </p:blipFill>
+        <p:spPr>
+          <a:xfrm>
+            <a:off x="4892040" y="1645920"/>
+            <a:ext cx="3886200" cy="2890202"/>
+          </a:xfrm>
+          <a:prstGeom prst="rect">
+            <a:avLst/>
+          </a:prstGeom>
+        </p:spPr>
+      </p:pic>
     </p:spTree>
     <p:extLst>
       <p:ext uri="{BB962C8B-B14F-4D97-AF65-F5344CB8AC3E}">
@@ -9792,7 +10084,106 @@
                 <a:ea typeface="Calibri"/>
                 <a:cs typeface="Calibri"/>
               </a:rPr>
-              <a:t>ΔU = I · Rslinga     Ulast = Ukälla − ΔU</a:t>
+              <a:t>ΔU = I · </a:t>
+            </a:r>
+            <a:r>
+              <a:rPr sz="2400" b="1">
+                <a:solidFill>
+                  <a:srgbClr val="064F91"/>
+                </a:solidFill>
+                <a:latin typeface="Calibri"/>
+                <a:ea typeface="Calibri"/>
+                <a:cs typeface="Calibri"/>
+              </a:rPr>
+              <a:t>R</a:t>
+            </a:r>
+            <a:r>
+              <a:rPr sz="2400" b="1" baseline="-25000">
+                <a:solidFill>
+                  <a:srgbClr val="064F91"/>
+                </a:solidFill>
+                <a:latin typeface="Calibri"/>
+                <a:ea typeface="Calibri"/>
+                <a:cs typeface="Calibri"/>
+              </a:rPr>
+              <a:t>slinga</a:t>
+            </a:r>
+            <a:r>
+              <a:rPr sz="2400" b="1">
+                <a:solidFill>
+                  <a:srgbClr val="064F91"/>
+                </a:solidFill>
+                <a:latin typeface="Calibri"/>
+                <a:ea typeface="Calibri"/>
+                <a:cs typeface="Calibri"/>
+              </a:rPr>
+              <a:t>     </a:t>
+            </a:r>
+            <a:r>
+              <a:rPr sz="2400" b="1">
+                <a:solidFill>
+                  <a:srgbClr val="064F91"/>
+                </a:solidFill>
+                <a:latin typeface="Calibri"/>
+                <a:ea typeface="Calibri"/>
+                <a:cs typeface="Calibri"/>
+              </a:rPr>
+              <a:t>U</a:t>
+            </a:r>
+            <a:r>
+              <a:rPr sz="2400" b="1" baseline="-25000">
+                <a:solidFill>
+                  <a:srgbClr val="064F91"/>
+                </a:solidFill>
+                <a:latin typeface="Calibri"/>
+                <a:ea typeface="Calibri"/>
+                <a:cs typeface="Calibri"/>
+              </a:rPr>
+              <a:t>last</a:t>
+            </a:r>
+            <a:r>
+              <a:rPr sz="2400" b="1">
+                <a:solidFill>
+                  <a:srgbClr val="064F91"/>
+                </a:solidFill>
+                <a:latin typeface="Calibri"/>
+                <a:ea typeface="Calibri"/>
+                <a:cs typeface="Calibri"/>
+              </a:rPr>
+              <a:t> = </a:t>
+            </a:r>
+            <a:r>
+              <a:rPr sz="2400" b="1">
+                <a:solidFill>
+                  <a:srgbClr val="064F91"/>
+                </a:solidFill>
+                <a:latin typeface="Calibri"/>
+                <a:ea typeface="Calibri"/>
+                <a:cs typeface="Calibri"/>
+              </a:rPr>
+              <a:t>U</a:t>
+            </a:r>
+            <a:r>
+              <a:rPr sz="2400" b="1" baseline="-25000">
+                <a:solidFill>
+                  <a:srgbClr val="064F91"/>
+                </a:solidFill>
+                <a:latin typeface="Calibri"/>
+                <a:ea typeface="Calibri"/>
+                <a:cs typeface="Calibri"/>
+              </a:rPr>
+              <a:t>källa</a:t>
+            </a:r>
+            <a:r>
+              <a:rPr sz="2400" b="1">
+                <a:solidFill>
+                  <a:srgbClr val="064F91"/>
+                </a:solidFill>
+                <a:latin typeface="Calibri"/>
+                <a:ea typeface="Calibri"/>
+                <a:cs typeface="Calibri"/>
+              </a:rPr>
+              <a:t> − ΔU</a:t>
             </a:r>
           </a:p>
         </p:txBody>
@@ -9849,7 +10240,29 @@
                 <a:ea typeface="Calibri"/>
                 <a:cs typeface="Calibri"/>
               </a:rPr>
-              <a:t>Rslinga omfattar både fram- och returväg. U och ΔU anges i V, I i A och R i Ω.</a:t>
+              <a:t>R</a:t>
+            </a:r>
+            <a:r>
+              <a:rPr sz="2100" b="0" baseline="-25000">
+                <a:solidFill>
+                  <a:srgbClr val="111111"/>
+                </a:solidFill>
+                <a:latin typeface="Calibri"/>
+                <a:ea typeface="Calibri"/>
+                <a:cs typeface="Calibri"/>
+              </a:rPr>
+              <a:t>slinga</a:t>
+            </a:r>
+            <a:r>
+              <a:rPr sz="2100" b="0">
+                <a:solidFill>
+                  <a:srgbClr val="111111"/>
+                </a:solidFill>
+                <a:latin typeface="Calibri"/>
+                <a:ea typeface="Calibri"/>
+                <a:cs typeface="Calibri"/>
+              </a:rPr>
+              <a:t> omfattar både fram- och returväg. U och ΔU anges i V, I i A och R i Ω.</a:t>
             </a:r>
           </a:p>
         </p:txBody>
@@ -9906,7 +10319,73 @@
                 <a:ea typeface="Calibri"/>
                 <a:cs typeface="Calibri"/>
               </a:rPr>
-              <a:t>Förutsättningar: Konstant DC: Ukälla = 24 V, I = 6 A, Rslinga = 0,15 Ω.</a:t>
+              <a:t>Förutsättningar: Konstant DC: </a:t>
+            </a:r>
+            <a:r>
+              <a:rPr sz="2025" b="0">
+                <a:solidFill>
+                  <a:srgbClr val="111111"/>
+                </a:solidFill>
+                <a:latin typeface="Calibri"/>
+                <a:ea typeface="Calibri"/>
+                <a:cs typeface="Calibri"/>
+              </a:rPr>
+              <a:t>U</a:t>
+            </a:r>
+            <a:r>
+              <a:rPr sz="2025" b="0" baseline="-25000">
+                <a:solidFill>
+                  <a:srgbClr val="111111"/>
+                </a:solidFill>
+                <a:latin typeface="Calibri"/>
+                <a:ea typeface="Calibri"/>
+                <a:cs typeface="Calibri"/>
+              </a:rPr>
+              <a:t>källa</a:t>
+            </a:r>
+            <a:r>
+              <a:rPr sz="2025" b="0">
+                <a:solidFill>
+                  <a:srgbClr val="111111"/>
+                </a:solidFill>
+                <a:latin typeface="Calibri"/>
+                <a:ea typeface="Calibri"/>
+                <a:cs typeface="Calibri"/>
+              </a:rPr>
+              <a:t> = 24 V, I = 6 A, </a:t>
+            </a:r>
+            <a:r>
+              <a:rPr sz="2025" b="0">
+                <a:solidFill>
+                  <a:srgbClr val="111111"/>
+                </a:solidFill>
+                <a:latin typeface="Calibri"/>
+                <a:ea typeface="Calibri"/>
+                <a:cs typeface="Calibri"/>
+              </a:rPr>
+              <a:t>R</a:t>
+            </a:r>
+            <a:r>
+              <a:rPr sz="2025" b="0" baseline="-25000">
+                <a:solidFill>
+                  <a:srgbClr val="111111"/>
+                </a:solidFill>
+                <a:latin typeface="Calibri"/>
+                <a:ea typeface="Calibri"/>
+                <a:cs typeface="Calibri"/>
+              </a:rPr>
+              <a:t>slinga</a:t>
+            </a:r>
+            <a:r>
+              <a:rPr sz="2025" b="0">
+                <a:solidFill>
+                  <a:srgbClr val="111111"/>
+                </a:solidFill>
+                <a:latin typeface="Calibri"/>
+                <a:ea typeface="Calibri"/>
+                <a:cs typeface="Calibri"/>
+              </a:rPr>
+              <a:t> = 0,15 Ω.</a:t>
             </a:r>
           </a:p>
         </p:txBody>
@@ -10204,7 +10683,7 @@
         <p:spPr>
           <a:xfrm xmlns:a="http://schemas.openxmlformats.org/drawingml/2006/main">
             <a:off x="762000" y="2533650"/>
-            <a:ext cx="7620000" cy="2286000"/>
+            <a:ext cx="3886200" cy="2606040"/>
           </a:xfrm>
           <a:prstGeom xmlns:a="http://schemas.openxmlformats.org/drawingml/2006/main" prst="rect">
             <a:avLst/>
@@ -10240,7 +10719,7 @@
                 <a:ea typeface="Calibri"/>
                 <a:cs typeface="Calibri"/>
               </a:rPr>
-              <a:t>En 24 V-last tar 6 A. Slingresistansen i matningen är 0,15 Ω. Beräkna spänningsfallet och lastspänningen.</a:t>
+              <a:t>En 24 V-last tar 6 A. Slingresistansen i matningen är 0,15 Ω. Beräkna spänningsfallet och lastspänningen.</a:t>
             </a:r>
           </a:p>
         </p:txBody>
@@ -10361,6 +10840,30 @@
           </a:p>
         </p:txBody>
       </p:sp>
+      <p:pic xmlns:a="http://schemas.openxmlformats.org/drawingml/2006/main" xmlns:r="http://schemas.openxmlformats.org/officeDocument/2006/relationships">
+        <p:nvPicPr>
+          <p:cNvPr id="9" name="Figur: 24 V-matning till en last som tar 6 A vi" descr="24 V-matning till en last som tar 6 A via ledningar med slingresistansen 0,15 ohm; spänningsfall och lastspänning okända"/>
+          <p:cNvPicPr>
+            <a:picLocks noChangeAspect="1"/>
+          </p:cNvPicPr>
+          <p:nvPr/>
+        </p:nvPicPr>
+        <p:blipFill>
+          <a:blip r:embed="rId3"/>
+          <a:stretch>
+            <a:fillRect/>
+          </a:stretch>
+        </p:blipFill>
+        <p:spPr>
+          <a:xfrm>
+            <a:off x="4846320" y="2331720"/>
+            <a:ext cx="3931920" cy="2740984"/>
+          </a:xfrm>
+          <a:prstGeom prst="rect">
+            <a:avLst/>
+          </a:prstGeom>
+        </p:spPr>
+      </p:pic>
     </p:spTree>
     <p:extLst>
       <p:ext uri="{BB962C8B-B14F-4D97-AF65-F5344CB8AC3E}">
@@ -10516,7 +11019,29 @@
                 <a:ea typeface="Calibri"/>
                 <a:cs typeface="Calibri"/>
               </a:rPr>
-              <a:t>Iₖ ≈ U₀/Zs</a:t>
+              <a:t>Iₖ ≈ U₀/</a:t>
+            </a:r>
+            <a:r>
+              <a:rPr sz="2400" b="1">
+                <a:solidFill>
+                  <a:srgbClr val="064F91"/>
+                </a:solidFill>
+                <a:latin typeface="Calibri"/>
+                <a:ea typeface="Calibri"/>
+                <a:cs typeface="Calibri"/>
+              </a:rPr>
+              <a:t>Z</a:t>
+            </a:r>
+            <a:r>
+              <a:rPr sz="2400" b="1" baseline="-25000">
+                <a:solidFill>
+                  <a:srgbClr val="064F91"/>
+                </a:solidFill>
+                <a:latin typeface="Calibri"/>
+                <a:ea typeface="Calibri"/>
+                <a:cs typeface="Calibri"/>
+              </a:rPr>
+              <a:t>s</a:t>
             </a:r>
           </a:p>
         </p:txBody>
@@ -10573,7 +11098,40 @@
                 <a:ea typeface="Calibri"/>
                 <a:cs typeface="Calibri"/>
               </a:rPr>
-              <a:t>Iₖ är beräknad felström, U₀ drivande spänning och Zs hela felströmsslingans impedansbelopp.</a:t>
+              <a:t>Iₖ är beräknad felström, U₀ drivande spänning och </a:t>
+            </a:r>
+            <a:r>
+              <a:rPr sz="2100" b="0">
+                <a:solidFill>
+                  <a:srgbClr val="111111"/>
+                </a:solidFill>
+                <a:latin typeface="Calibri"/>
+                <a:ea typeface="Calibri"/>
+                <a:cs typeface="Calibri"/>
+              </a:rPr>
+              <a:t>Z</a:t>
+            </a:r>
+            <a:r>
+              <a:rPr sz="2100" b="0" baseline="-25000">
+                <a:solidFill>
+                  <a:srgbClr val="111111"/>
+                </a:solidFill>
+                <a:latin typeface="Calibri"/>
+                <a:ea typeface="Calibri"/>
+                <a:cs typeface="Calibri"/>
+              </a:rPr>
+              <a:t>s</a:t>
+            </a:r>
+            <a:r>
+              <a:rPr sz="2100" b="0">
+                <a:solidFill>
+                  <a:srgbClr val="111111"/>
+                </a:solidFill>
+                <a:latin typeface="Calibri"/>
+                <a:ea typeface="Calibri"/>
+                <a:cs typeface="Calibri"/>
+              </a:rPr>
+              <a:t> hela felströmsslingans impedansbelopp.</a:t>
             </a:r>
           </a:p>
         </p:txBody>
@@ -10630,7 +11188,40 @@
                 <a:ea typeface="Calibri"/>
                 <a:cs typeface="Calibri"/>
               </a:rPr>
-              <a:t>Förutsättningar: Förenklad modell: U₀ = 230 V och Zs = 0,46 Ω.</a:t>
+              <a:t>Förutsättningar: Förenklad modell: U₀ = 230 V och </a:t>
+            </a:r>
+            <a:r>
+              <a:rPr sz="2025" b="0">
+                <a:solidFill>
+                  <a:srgbClr val="111111"/>
+                </a:solidFill>
+                <a:latin typeface="Calibri"/>
+                <a:ea typeface="Calibri"/>
+                <a:cs typeface="Calibri"/>
+              </a:rPr>
+              <a:t>Z</a:t>
+            </a:r>
+            <a:r>
+              <a:rPr sz="2025" b="0" baseline="-25000">
+                <a:solidFill>
+                  <a:srgbClr val="111111"/>
+                </a:solidFill>
+                <a:latin typeface="Calibri"/>
+                <a:ea typeface="Calibri"/>
+                <a:cs typeface="Calibri"/>
+              </a:rPr>
+              <a:t>s</a:t>
+            </a:r>
+            <a:r>
+              <a:rPr sz="2025" b="0">
+                <a:solidFill>
+                  <a:srgbClr val="111111"/>
+                </a:solidFill>
+                <a:latin typeface="Calibri"/>
+                <a:ea typeface="Calibri"/>
+                <a:cs typeface="Calibri"/>
+              </a:rPr>
+              <a:t> = 0,46 Ω.</a:t>
             </a:r>
           </a:p>
         </p:txBody>
@@ -10928,7 +11519,7 @@
         <p:spPr>
           <a:xfrm xmlns:a="http://schemas.openxmlformats.org/drawingml/2006/main">
             <a:off x="762000" y="2533650"/>
-            <a:ext cx="7620000" cy="2286000"/>
+            <a:ext cx="3886200" cy="2606040"/>
           </a:xfrm>
           <a:prstGeom xmlns:a="http://schemas.openxmlformats.org/drawingml/2006/main" prst="rect">
             <a:avLst/>
@@ -10964,7 +11555,40 @@
                 <a:ea typeface="Calibri"/>
                 <a:cs typeface="Calibri"/>
               </a:rPr>
-              <a:t>I en beräkningsmodell är U₀ = 230 V och Zs = 0,46 Ω. Beräkna Iₖ.</a:t>
+              <a:t>I en beräkningsmodell är U₀ = 230 V och </a:t>
+            </a:r>
+            <a:r>
+              <a:rPr sz="2400" b="0">
+                <a:solidFill>
+                  <a:srgbClr val="111111"/>
+                </a:solidFill>
+                <a:latin typeface="Calibri"/>
+                <a:ea typeface="Calibri"/>
+                <a:cs typeface="Calibri"/>
+              </a:rPr>
+              <a:t>Z</a:t>
+            </a:r>
+            <a:r>
+              <a:rPr sz="2400" b="0" baseline="-25000">
+                <a:solidFill>
+                  <a:srgbClr val="111111"/>
+                </a:solidFill>
+                <a:latin typeface="Calibri"/>
+                <a:ea typeface="Calibri"/>
+                <a:cs typeface="Calibri"/>
+              </a:rPr>
+              <a:t>s</a:t>
+            </a:r>
+            <a:r>
+              <a:rPr sz="2400" b="0">
+                <a:solidFill>
+                  <a:srgbClr val="111111"/>
+                </a:solidFill>
+                <a:latin typeface="Calibri"/>
+                <a:ea typeface="Calibri"/>
+                <a:cs typeface="Calibri"/>
+              </a:rPr>
+              <a:t> = 0,46 Ω. Beräkna Iₖ.</a:t>
             </a:r>
           </a:p>
         </p:txBody>
@@ -11085,6 +11709,30 @@
           </a:p>
         </p:txBody>
       </p:sp>
+      <p:pic xmlns:a="http://schemas.openxmlformats.org/drawingml/2006/main" xmlns:r="http://schemas.openxmlformats.org/officeDocument/2006/relationships">
+        <p:nvPicPr>
+          <p:cNvPr id="9" name="Figur: Förenklad felströmsslinga med U0 = 230 V" descr="Förenklad felströmsslinga med U0 = 230 V och Zs = 0,46 ohm; felströmmen okänd"/>
+          <p:cNvPicPr>
+            <a:picLocks noChangeAspect="1"/>
+          </p:cNvPicPr>
+          <p:nvPr/>
+        </p:nvPicPr>
+        <p:blipFill>
+          <a:blip r:embed="rId3"/>
+          <a:stretch>
+            <a:fillRect/>
+          </a:stretch>
+        </p:blipFill>
+        <p:spPr>
+          <a:xfrm>
+            <a:off x="4846320" y="2331720"/>
+            <a:ext cx="3931920" cy="2740984"/>
+          </a:xfrm>
+          <a:prstGeom prst="rect">
+            <a:avLst/>
+          </a:prstGeom>
+        </p:spPr>
+      </p:pic>
     </p:spTree>
     <p:extLst>
       <p:ext uri="{BB962C8B-B14F-4D97-AF65-F5344CB8AC3E}">
@@ -11297,7 +11945,40 @@
                 <a:ea typeface="Calibri"/>
                 <a:cs typeface="Calibri"/>
               </a:rPr>
-              <a:t>Index 1 och 2 betecknar två fall. Vid samma U₀ är strömmen omvänt proportionell mot Zs.</a:t>
+              <a:t>Index 1 och 2 betecknar två fall. Vid samma U₀ är strömmen omvänt proportionell mot </a:t>
+            </a:r>
+            <a:r>
+              <a:rPr sz="2100" b="0">
+                <a:solidFill>
+                  <a:srgbClr val="111111"/>
+                </a:solidFill>
+                <a:latin typeface="Calibri"/>
+                <a:ea typeface="Calibri"/>
+                <a:cs typeface="Calibri"/>
+              </a:rPr>
+              <a:t>Z</a:t>
+            </a:r>
+            <a:r>
+              <a:rPr sz="2100" b="0" baseline="-25000">
+                <a:solidFill>
+                  <a:srgbClr val="111111"/>
+                </a:solidFill>
+                <a:latin typeface="Calibri"/>
+                <a:ea typeface="Calibri"/>
+                <a:cs typeface="Calibri"/>
+              </a:rPr>
+              <a:t>s</a:t>
+            </a:r>
+            <a:r>
+              <a:rPr sz="2100" b="0">
+                <a:solidFill>
+                  <a:srgbClr val="111111"/>
+                </a:solidFill>
+                <a:latin typeface="Calibri"/>
+                <a:ea typeface="Calibri"/>
+                <a:cs typeface="Calibri"/>
+              </a:rPr>
+              <a:t>.</a:t>
             </a:r>
           </a:p>
         </p:txBody>
@@ -12202,7 +12883,29 @@
                 <a:ea typeface="Calibri"/>
                 <a:cs typeface="Calibri"/>
               </a:rPr>
-              <a:t>Zs ökar från 0,46 till 0,92 Ω vid oförändrade 230 V. Hur ändras felströmmen?</a:t>
+              <a:t>Z</a:t>
+            </a:r>
+            <a:r>
+              <a:rPr sz="2400" b="0" baseline="-25000">
+                <a:solidFill>
+                  <a:srgbClr val="111111"/>
+                </a:solidFill>
+                <a:latin typeface="Calibri"/>
+                <a:ea typeface="Calibri"/>
+                <a:cs typeface="Calibri"/>
+              </a:rPr>
+              <a:t>s</a:t>
+            </a:r>
+            <a:r>
+              <a:rPr sz="2400" b="0">
+                <a:solidFill>
+                  <a:srgbClr val="111111"/>
+                </a:solidFill>
+                <a:latin typeface="Calibri"/>
+                <a:ea typeface="Calibri"/>
+                <a:cs typeface="Calibri"/>
+              </a:rPr>
+              <a:t> ökar från 0,46 till 0,92 Ω vid oförändrade 230 V. Hur ändras felströmmen?</a:t>
             </a:r>
           </a:p>
         </p:txBody>
@@ -14414,64 +15117,6 @@
       </p:sp>
       <p:sp>
         <p:nvSpPr>
-          <p:cNvPr id="7" name="Källor och lärarstöd finns även i bildanteckningarna.">
-            <a:extLst xmlns:a="http://schemas.openxmlformats.org/drawingml/2006/main">
-              <a:ext uri="{FF2B5EF4-FFF2-40B4-BE49-F238E27FC236}">
-                <a16:creationId xmlns:a16="http://schemas.microsoft.com/office/drawing/2014/main" id="{A84445C5-569D-4416-85E7-DFE62B84E947}"/>
-              </a:ext>
-            </a:extLst>
-          </p:cNvPr>
-          <p:cNvSpPr>
-            <a:spLocks xmlns:a="http://schemas.openxmlformats.org/drawingml/2006/main" noGrp="1"/>
-          </p:cNvSpPr>
-          <p:nvPr/>
-        </p:nvSpPr>
-        <p:spPr>
-          <a:xfrm xmlns:a="http://schemas.openxmlformats.org/drawingml/2006/main">
-            <a:off x="762000" y="5676900"/>
-            <a:ext cx="7620000" cy="352425"/>
-          </a:xfrm>
-          <a:prstGeom xmlns:a="http://schemas.openxmlformats.org/drawingml/2006/main" prst="rect">
-            <a:avLst/>
-          </a:prstGeom>
-          <a:noFill xmlns:a="http://schemas.openxmlformats.org/drawingml/2006/main"/>
-          <a:ln xmlns:a="http://schemas.openxmlformats.org/drawingml/2006/main" w="0">
-            <a:noFill/>
-          </a:ln>
-        </p:spPr>
-        <p:txBody>
-          <a:bodyPr xmlns:a="http://schemas.openxmlformats.org/drawingml/2006/main" wrap="square" lIns="0" tIns="0" rIns="0" bIns="0" anchor="t">
-            <a:noAutofit/>
-          </a:bodyPr>
-          <a:lstStyle xmlns:a="http://schemas.openxmlformats.org/drawingml/2006/main"/>
-          <a:p xmlns:a="http://schemas.openxmlformats.org/drawingml/2006/main">
-            <a:pPr algn="l">
-              <a:buNone/>
-              <a:defRPr sz="1800" b="0">
-                <a:solidFill>
-                  <a:srgbClr val="111111"/>
-                </a:solidFill>
-                <a:latin typeface="Calibri"/>
-                <a:ea typeface="Calibri"/>
-                <a:cs typeface="Calibri"/>
-              </a:defRPr>
-            </a:pPr>
-            <a:r>
-              <a:rPr sz="1800" b="0">
-                <a:solidFill>
-                  <a:srgbClr val="111111"/>
-                </a:solidFill>
-                <a:latin typeface="Calibri"/>
-                <a:ea typeface="Calibri"/>
-                <a:cs typeface="Calibri"/>
-              </a:rPr>
-              <a:t>Källor och lärarstöd finns även i bildanteckningarna.</a:t>
-            </a:r>
-          </a:p>
-        </p:txBody>
-      </p:sp>
-      <p:sp>
-        <p:nvSpPr>
           <p:cNvPr id="8" name="22">
             <a:extLst xmlns:a="http://schemas.openxmlformats.org/drawingml/2006/main">
               <a:ext uri="{FF2B5EF4-FFF2-40B4-BE49-F238E27FC236}">
@@ -14854,7 +15499,29 @@
                 <a:ea typeface="Calibri"/>
                 <a:cs typeface="Calibri"/>
               </a:rPr>
-              <a:t>Zs är felströmsslingans impedans. Dess belopp påverkar tillgänglig felström.</a:t>
+              <a:t>Z</a:t>
+            </a:r>
+            <a:r>
+              <a:rPr sz="2250" b="0" baseline="-25000">
+                <a:solidFill>
+                  <a:srgbClr val="111111"/>
+                </a:solidFill>
+                <a:latin typeface="Calibri"/>
+                <a:ea typeface="Calibri"/>
+                <a:cs typeface="Calibri"/>
+              </a:rPr>
+              <a:t>s</a:t>
+            </a:r>
+            <a:r>
+              <a:rPr sz="2250" b="0">
+                <a:solidFill>
+                  <a:srgbClr val="111111"/>
+                </a:solidFill>
+                <a:latin typeface="Calibri"/>
+                <a:ea typeface="Calibri"/>
+                <a:cs typeface="Calibri"/>
+              </a:rPr>
+              <a:t> är felströmsslingans impedans. Dess belopp påverkar tillgänglig felström.</a:t>
             </a:r>
           </a:p>
         </p:txBody>
@@ -16570,7 +17237,7 @@
         <p:spPr>
           <a:xfrm xmlns:a="http://schemas.openxmlformats.org/drawingml/2006/main">
             <a:off x="762000" y="1619250"/>
-            <a:ext cx="7620000" cy="1466850"/>
+            <a:ext cx="3977639" cy="1466850"/>
           </a:xfrm>
           <a:prstGeom xmlns:a="http://schemas.openxmlformats.org/drawingml/2006/main" prst="rect">
             <a:avLst/>
@@ -16598,7 +17265,7 @@
               </a:defRPr>
             </a:pPr>
             <a:r>
-              <a:rPr sz="2400" b="0">
+              <a:rPr sz="1800" b="0">
                 <a:solidFill>
                   <a:srgbClr val="111111"/>
                 </a:solidFill>
@@ -16622,7 +17289,7 @@
               </a:defRPr>
             </a:pPr>
             <a:r>
-              <a:rPr sz="2400" b="0">
+              <a:rPr sz="1800" b="0">
                 <a:solidFill>
                   <a:srgbClr val="111111"/>
                 </a:solidFill>
@@ -16652,7 +17319,7 @@
         <p:spPr>
           <a:xfrm xmlns:a="http://schemas.openxmlformats.org/drawingml/2006/main">
             <a:off x="762000" y="3200400"/>
-            <a:ext cx="7620000" cy="838200"/>
+            <a:ext cx="3977639" cy="838200"/>
           </a:xfrm>
           <a:prstGeom xmlns:a="http://schemas.openxmlformats.org/drawingml/2006/main" prst="rect">
             <a:avLst/>
@@ -16680,7 +17347,7 @@
               </a:defRPr>
             </a:pPr>
             <a:r>
-              <a:rPr sz="2925" b="1">
+              <a:rPr sz="2650" b="1">
                 <a:solidFill>
                   <a:srgbClr val="064F91"/>
                 </a:solidFill>
@@ -16710,7 +17377,7 @@
         <p:spPr>
           <a:xfrm xmlns:a="http://schemas.openxmlformats.org/drawingml/2006/main">
             <a:off x="762000" y="4429125"/>
-            <a:ext cx="7620000" cy="1352550"/>
+            <a:ext cx="3977639" cy="1352550"/>
           </a:xfrm>
           <a:prstGeom xmlns:a="http://schemas.openxmlformats.org/drawingml/2006/main" prst="rect">
             <a:avLst/>
@@ -16738,7 +17405,7 @@
               </a:defRPr>
             </a:pPr>
             <a:r>
-              <a:rPr sz="2250" b="0">
+              <a:rPr sz="1800" b="0">
                 <a:solidFill>
                   <a:srgbClr val="111111"/>
                 </a:solidFill>
@@ -16762,7 +17429,7 @@
               </a:defRPr>
             </a:pPr>
             <a:r>
-              <a:rPr sz="2250" b="0">
+              <a:rPr sz="1800" b="0">
                 <a:solidFill>
                   <a:srgbClr val="111111"/>
                 </a:solidFill>
@@ -16833,6 +17500,30 @@
           </a:p>
         </p:txBody>
       </p:sp>
+      <p:pic xmlns:a="http://schemas.openxmlformats.org/drawingml/2006/main" xmlns:r="http://schemas.openxmlformats.org/officeDocument/2006/relationships">
+        <p:nvPicPr>
+          <p:cNvPr id="9" name="Figur: TN-S-system: källan med L1, L2, L3, N oc" descr="TN-S-system: källan med L1, L2, L3, N och PE; ett fel mellan L1 och höljet ger en felslinga via PE tillbaka till källan"/>
+          <p:cNvPicPr>
+            <a:picLocks noChangeAspect="1"/>
+          </p:cNvPicPr>
+          <p:nvPr/>
+        </p:nvPicPr>
+        <p:blipFill>
+          <a:blip r:embed="rId3"/>
+          <a:stretch>
+            <a:fillRect/>
+          </a:stretch>
+        </p:blipFill>
+        <p:spPr>
+          <a:xfrm>
+            <a:off x="4892040" y="1645920"/>
+            <a:ext cx="3886200" cy="3252383"/>
+          </a:xfrm>
+          <a:prstGeom prst="rect">
+            <a:avLst/>
+          </a:prstGeom>
+        </p:spPr>
+      </p:pic>
     </p:spTree>
     <p:extLst>
       <p:ext uri="{BB962C8B-B14F-4D97-AF65-F5344CB8AC3E}">
@@ -16954,7 +17645,7 @@
         <p:spPr>
           <a:xfrm xmlns:a="http://schemas.openxmlformats.org/drawingml/2006/main">
             <a:off x="762000" y="1619250"/>
-            <a:ext cx="7620000" cy="1466850"/>
+            <a:ext cx="3977639" cy="1466850"/>
           </a:xfrm>
           <a:prstGeom xmlns:a="http://schemas.openxmlformats.org/drawingml/2006/main" prst="rect">
             <a:avLst/>
@@ -16982,7 +17673,7 @@
               </a:defRPr>
             </a:pPr>
             <a:r>
-              <a:rPr sz="2400" b="0">
+              <a:rPr sz="1800" b="0">
                 <a:solidFill>
                   <a:srgbClr val="111111"/>
                 </a:solidFill>
@@ -17006,7 +17697,7 @@
               </a:defRPr>
             </a:pPr>
             <a:r>
-              <a:rPr sz="2400" b="0">
+              <a:rPr sz="1800" b="0">
                 <a:solidFill>
                   <a:srgbClr val="111111"/>
                 </a:solidFill>
@@ -17036,7 +17727,7 @@
         <p:spPr>
           <a:xfrm xmlns:a="http://schemas.openxmlformats.org/drawingml/2006/main">
             <a:off x="762000" y="3200400"/>
-            <a:ext cx="7620000" cy="838200"/>
+            <a:ext cx="3977639" cy="838200"/>
           </a:xfrm>
           <a:prstGeom xmlns:a="http://schemas.openxmlformats.org/drawingml/2006/main" prst="rect">
             <a:avLst/>
@@ -17064,7 +17755,7 @@
               </a:defRPr>
             </a:pPr>
             <a:r>
-              <a:rPr sz="2925" b="1">
+              <a:rPr sz="2650" b="1">
                 <a:solidFill>
                   <a:srgbClr val="064F91"/>
                 </a:solidFill>
@@ -17094,7 +17785,7 @@
         <p:spPr>
           <a:xfrm xmlns:a="http://schemas.openxmlformats.org/drawingml/2006/main">
             <a:off x="762000" y="4429125"/>
-            <a:ext cx="7620000" cy="1352550"/>
+            <a:ext cx="3977639" cy="1352550"/>
           </a:xfrm>
           <a:prstGeom xmlns:a="http://schemas.openxmlformats.org/drawingml/2006/main" prst="rect">
             <a:avLst/>
@@ -17122,7 +17813,7 @@
               </a:defRPr>
             </a:pPr>
             <a:r>
-              <a:rPr sz="2250" b="0">
+              <a:rPr sz="2100" b="0">
                 <a:solidFill>
                   <a:srgbClr val="111111"/>
                 </a:solidFill>
@@ -17146,7 +17837,7 @@
               </a:defRPr>
             </a:pPr>
             <a:r>
-              <a:rPr sz="2250" b="0">
+              <a:rPr sz="2100" b="0">
                 <a:solidFill>
                   <a:srgbClr val="111111"/>
                 </a:solidFill>
@@ -17217,6 +17908,30 @@
           </a:p>
         </p:txBody>
       </p:sp>
+      <p:pic xmlns:a="http://schemas.openxmlformats.org/drawingml/2006/main" xmlns:r="http://schemas.openxmlformats.org/officeDocument/2006/relationships">
+        <p:nvPicPr>
+          <p:cNvPr id="9" name="Figur: TT-system: källans systemjord RB och ins" descr="TT-system: källans systemjord RB och installationens jordtag RA; felströmmen går genom jorden mellan jordtagen"/>
+          <p:cNvPicPr>
+            <a:picLocks noChangeAspect="1"/>
+          </p:cNvPicPr>
+          <p:nvPr/>
+        </p:nvPicPr>
+        <p:blipFill>
+          <a:blip r:embed="rId3"/>
+          <a:stretch>
+            <a:fillRect/>
+          </a:stretch>
+        </p:blipFill>
+        <p:spPr>
+          <a:xfrm>
+            <a:off x="4892040" y="1645920"/>
+            <a:ext cx="3886200" cy="3252383"/>
+          </a:xfrm>
+          <a:prstGeom prst="rect">
+            <a:avLst/>
+          </a:prstGeom>
+        </p:spPr>
+      </p:pic>
     </p:spTree>
     <p:extLst>
       <p:ext uri="{BB962C8B-B14F-4D97-AF65-F5344CB8AC3E}">

</xml_diff>

<commit_message>
Vecka 44–45: rättelser efter granskning (lärare, elinstallatör, sjöingenjör)
- Exempel som inte ger övningarnas svar: felström vid 2,3 Ω, mätintervall som klarar
  respektive inte klarar kravet, fram/retur 2,1/0,9 V, delare 2 + 2 kΩ, omvänd
  halveringsövning, reläskyddsövning med hjälpspänning
- Fartyg: jordfelsspårning med läckströmstång, isolationsprovning ombord (500 V DC,
  urladdning), oscilloskop i IT-nät, TT ovanligt ombord, återgång med arbetstillstånd,
  isolationsvakt och maskindagbok
- Figurer: N och PE förbundna vid källan, isolationsvakt galvaniskt ansluten,
  tydligare halveringsetiketter, nya exempelvärden
- Filmen IT-nätet ombord: läckström via kablarnas kapacitans, säker felspårning i
  samråd med vakthavande, skydd på båda förbrukarna
- Hopskrivna formler får mellanrum så att index blir rätt

Co-Authored-By: Claude Opus 5.5 <noreply@anthropic.com>
Claude-Session: https://claude.ai/code/session_011V9KjBb53XrDm23Dw58SH3
</commit_message>
<xml_diff>
--- a/sjoskolan/vecka-44/aktuell/v44_01_Lagspanningssystem_elev.pptx
+++ b/sjoskolan/vecka-44/aktuell/v44_01_Lagspanningssystem_elev.pptx
@@ -9730,7 +9730,7 @@
                 <a:ea typeface="Calibri"/>
                 <a:cs typeface="Calibri"/>
               </a:rPr>
-              <a:t> fördubblas till 1,15 Ω blir Iₖ ≈ 230/1,15 = 200 A.</a:t>
+              <a:t> ökar till 2,3 Ω blir Iₖ ≈ 230/2,3 = 100 A.</a:t>
             </a:r>
           </a:p>
           <a:p xmlns:a="http://schemas.openxmlformats.org/drawingml/2006/main">
@@ -9907,7 +9907,7 @@
       </p:sp>
       <p:pic xmlns:a="http://schemas.openxmlformats.org/drawingml/2006/main" xmlns:r="http://schemas.openxmlformats.org/officeDocument/2006/relationships">
         <p:nvPicPr>
-          <p:cNvPr id="16" name="Figur: Felström som funktion av slingimpedans: " descr="Felström som funktion av slingimpedans: 0,575 ohm ger 400 A och 1,15 ohm ger 200 A"/>
+          <p:cNvPr id="16" name="Figur: Felström som funktion av slingimpedans: " descr="Felström som funktion av slingimpedans: 0,575 ohm ger 400 A och 2,3 ohm ger 100 A"/>
           <p:cNvPicPr>
             <a:picLocks noChangeAspect="1"/>
           </p:cNvPicPr>
@@ -11497,7 +11497,7 @@
                 <a:ea typeface="Calibri"/>
                 <a:cs typeface="Calibri"/>
               </a:rPr>
-              <a:t>Förenklad kortslutningsström</a:t>
+              <a:t>Förenklad felström</a:t>
             </a:r>
           </a:p>
         </p:txBody>
@@ -17813,15 +17813,15 @@
               </a:defRPr>
             </a:pPr>
             <a:r>
-              <a:rPr sz="2100" b="0">
-                <a:solidFill>
-                  <a:srgbClr val="111111"/>
-                </a:solidFill>
-                <a:latin typeface="Calibri"/>
-                <a:ea typeface="Calibri"/>
-                <a:cs typeface="Calibri"/>
-              </a:rPr>
-              <a:t>Jordtagsresistanser kan begränsa felströmmen så att</a:t>
+              <a:rPr sz="1700" b="0">
+                <a:solidFill>
+                  <a:srgbClr val="111111"/>
+                </a:solidFill>
+                <a:latin typeface="Calibri"/>
+                <a:ea typeface="Calibri"/>
+                <a:cs typeface="Calibri"/>
+              </a:rPr>
+              <a:t>Jordtagsresistanser kan begränsa felströmmen så att överströmsskydd ensamt inte ger avsedd bortkoppling.</a:t>
             </a:r>
           </a:p>
           <a:p xmlns:a="http://schemas.openxmlformats.org/drawingml/2006/main">
@@ -17837,15 +17837,15 @@
               </a:defRPr>
             </a:pPr>
             <a:r>
-              <a:rPr sz="2100" b="0">
-                <a:solidFill>
-                  <a:srgbClr val="111111"/>
-                </a:solidFill>
-                <a:latin typeface="Calibri"/>
-                <a:ea typeface="Calibri"/>
-                <a:cs typeface="Calibri"/>
-              </a:rPr>
-              <a:t>överströmsskydd ensamt inte ger avsedd bortkoppling.</a:t>
+              <a:rPr sz="1700" b="0">
+                <a:solidFill>
+                  <a:srgbClr val="111111"/>
+                </a:solidFill>
+                <a:latin typeface="Calibri"/>
+                <a:ea typeface="Calibri"/>
+                <a:cs typeface="Calibri"/>
+              </a:rPr>
+              <a:t>TT-system är ovanliga ombord.</a:t>
             </a:r>
           </a:p>
         </p:txBody>

</xml_diff>

<commit_message>
Sjöskolan vecka 44: rätta exempel, ledtrådar som gav svaret, 60 Hz i Isolationslabbet och Din förutsägelse i protokollen
Inaktuella exempel på övningssidorna, tolv ledtrådar som gav svaret, notation med index, IT-nätets
definition, enklare frågor. Isolationslabbet räknar fartygets 440 V-nät vid 60 Hz (uppgift 5 ger 287 mA),
rätt fysik i felsvaret och verkliga provfall. Labbprotokollen skriver Din förutsägelse; foten säger att
protokollet ingår i bedömningen. Inlämningen Analys av mätdata har värden som går att mäta.

Co-Authored-By: Claude Opus 5.5 <noreply@anthropic.com>
Claude-Session: https://claude.ai/code/session_01E6DNWu8trXB9zSZC1cgTtp
</commit_message>
<xml_diff>
--- a/sjoskolan/vecka-44/aktuell/v44_01_Lagspanningssystem_elev.pptx
+++ b/sjoskolan/vecka-44/aktuell/v44_01_Lagspanningssystem_elev.pptx
@@ -3847,7 +3847,7 @@
                 <a:ea typeface="Calibri"/>
                 <a:cs typeface="Calibri"/>
               </a:rPr>
-              <a:t>N leder normal returström, PE har skyddsfunktion</a:t>
+              <a:t>Jämför N och PE i normal drift och vid fel</a:t>
             </a:r>
           </a:p>
         </p:txBody>
@@ -3904,7 +3904,7 @@
                 <a:ea typeface="Calibri"/>
                 <a:cs typeface="Calibri"/>
               </a:rPr>
-              <a:t>I TN-S är neutralledare N och skyddsledare PE separata längs den berörda delen av systemet.</a:t>
+              <a:t>N är neutralledare och PE skyddsledare. Läs genomgången del 1, avsnitt 3: TN-system.</a:t>
             </a:r>
           </a:p>
         </p:txBody>
@@ -4018,7 +4018,7 @@
                 <a:ea typeface="Calibri"/>
                 <a:cs typeface="Calibri"/>
               </a:rPr>
-              <a:t>Arbetsgång: Jämför ledarnas uppgift i normaldrift och vid fel. Skilj funktion från ett tillfälligt lika potentialvärde.</a:t>
+              <a:t>Arbetsgång: Jämför vad ledarna gör i normal drift och vid fel. Titta på vad de gör, inte på vilken spänning de har.</a:t>
             </a:r>
           </a:p>
         </p:txBody>
@@ -4661,7 +4661,7 @@
                 <a:ea typeface="Calibri"/>
                 <a:cs typeface="Calibri"/>
               </a:rPr>
-              <a:t>Hög impedans i felslingan begränsar strömmen, så den kanske inte räcker för att ett överströmsskydd ska lösa ut.</a:t>
+              <a:t>I TT går felströmmen genom jorden mellan två jordtag. Jordtagen har resistans. Tänk på vad det gör med strömmens storlek.</a:t>
             </a:r>
           </a:p>
         </p:txBody>
@@ -5328,7 +5328,7 @@
                 <a:ea typeface="Calibri"/>
                 <a:cs typeface="Calibri"/>
               </a:rPr>
-              <a:t>IT-systemets isolation övervakas mot jord</a:t>
+              <a:t>Isolationsövervakning i IT-nät</a:t>
             </a:r>
           </a:p>
         </p:txBody>
@@ -5385,7 +5385,7 @@
                 <a:ea typeface="Calibri"/>
                 <a:cs typeface="Calibri"/>
               </a:rPr>
-              <a:t>Fasledarna är isolerade från jord eller anslutna via en hög impedans, och utsatta delar är skyddsjordade.</a:t>
+              <a:t>I ett IT-nät är faserna inte direkt kopplade till skrovet. Metallhöljen på apparaterna är kopplade till skrovet.</a:t>
             </a:r>
           </a:p>
         </p:txBody>
@@ -5776,7 +5776,7 @@
                 <a:ea typeface="Calibri"/>
                 <a:cs typeface="Calibri"/>
               </a:rPr>
-              <a:t>Vad övervakar isolationsvakten i ett IT-system, i princip?</a:t>
+              <a:t>Ett IT-nät har en isolationsvakt. Vad mäter den?</a:t>
             </a:r>
           </a:p>
         </p:txBody>
@@ -6500,7 +6500,7 @@
                 <a:ea typeface="Calibri"/>
                 <a:cs typeface="Calibri"/>
               </a:rPr>
-              <a:t>Isolationslarmet går i ett IT-system men lasten fortsätter. Varför är detta ingen grund för att ignorera larmet?</a:t>
+              <a:t>Isolationsvakten i ett IT-nät larmar. Lasten går ändå som vanligt. Varför får du inte strunta i larmet?</a:t>
             </a:r>
           </a:p>
         </p:txBody>
@@ -9166,7 +9166,40 @@
                 <a:ea typeface="Calibri"/>
                 <a:cs typeface="Calibri"/>
               </a:rPr>
-              <a:t> ≈ U₀/</a:t>
+              <a:t> ≈ </a:t>
+            </a:r>
+            <a:r>
+              <a:rPr sz="2925" b="1">
+                <a:solidFill>
+                  <a:srgbClr val="064F91"/>
+                </a:solidFill>
+                <a:latin typeface="Calibri"/>
+                <a:ea typeface="Calibri"/>
+                <a:cs typeface="Calibri"/>
+              </a:rPr>
+              <a:t>U</a:t>
+            </a:r>
+            <a:r>
+              <a:rPr sz="2925" b="1" baseline="-25000">
+                <a:solidFill>
+                  <a:srgbClr val="064F91"/>
+                </a:solidFill>
+                <a:latin typeface="Calibri"/>
+                <a:ea typeface="Calibri"/>
+                <a:cs typeface="Calibri"/>
+              </a:rPr>
+              <a:t>0</a:t>
+            </a:r>
+            <a:r>
+              <a:rPr sz="2925" b="1">
+                <a:solidFill>
+                  <a:srgbClr val="064F91"/>
+                </a:solidFill>
+                <a:latin typeface="Calibri"/>
+                <a:ea typeface="Calibri"/>
+                <a:cs typeface="Calibri"/>
+              </a:rPr>
+              <a:t>/</a:t>
             </a:r>
             <a:r>
               <a:rPr sz="2925" b="1">
@@ -9521,7 +9554,40 @@
                 <a:ea typeface="Calibri"/>
                 <a:cs typeface="Calibri"/>
               </a:rPr>
-              <a:t>En förenklad felströmsslinga har U₀ = 230 V och </a:t>
+              <a:t>En förenklad felströmsslinga har </a:t>
+            </a:r>
+            <a:r>
+              <a:rPr sz="2100" b="0">
+                <a:solidFill>
+                  <a:srgbClr val="111111"/>
+                </a:solidFill>
+                <a:latin typeface="Calibri"/>
+                <a:ea typeface="Calibri"/>
+                <a:cs typeface="Calibri"/>
+              </a:rPr>
+              <a:t>U</a:t>
+            </a:r>
+            <a:r>
+              <a:rPr sz="2100" b="0" baseline="-25000">
+                <a:solidFill>
+                  <a:srgbClr val="111111"/>
+                </a:solidFill>
+                <a:latin typeface="Calibri"/>
+                <a:ea typeface="Calibri"/>
+                <a:cs typeface="Calibri"/>
+              </a:rPr>
+              <a:t>0</a:t>
+            </a:r>
+            <a:r>
+              <a:rPr sz="2100" b="0">
+                <a:solidFill>
+                  <a:srgbClr val="111111"/>
+                </a:solidFill>
+                <a:latin typeface="Calibri"/>
+                <a:ea typeface="Calibri"/>
+                <a:cs typeface="Calibri"/>
+              </a:rPr>
+              <a:t> = 230 V och </a:t>
             </a:r>
             <a:r>
               <a:rPr sz="2100" b="0">
@@ -9633,7 +9699,40 @@
                 <a:ea typeface="Calibri"/>
                 <a:cs typeface="Calibri"/>
               </a:rPr>
-              <a:t> ≈ U₀/</a:t>
+              <a:t> ≈ </a:t>
+            </a:r>
+            <a:r>
+              <a:rPr sz="2325" b="1">
+                <a:solidFill>
+                  <a:srgbClr val="064F91"/>
+                </a:solidFill>
+                <a:latin typeface="Calibri"/>
+                <a:ea typeface="Calibri"/>
+                <a:cs typeface="Calibri"/>
+              </a:rPr>
+              <a:t>U</a:t>
+            </a:r>
+            <a:r>
+              <a:rPr sz="2325" b="1" baseline="-25000">
+                <a:solidFill>
+                  <a:srgbClr val="064F91"/>
+                </a:solidFill>
+                <a:latin typeface="Calibri"/>
+                <a:ea typeface="Calibri"/>
+                <a:cs typeface="Calibri"/>
+              </a:rPr>
+              <a:t>0</a:t>
+            </a:r>
+            <a:r>
+              <a:rPr sz="2325" b="1">
+                <a:solidFill>
+                  <a:srgbClr val="064F91"/>
+                </a:solidFill>
+                <a:latin typeface="Calibri"/>
+                <a:ea typeface="Calibri"/>
+                <a:cs typeface="Calibri"/>
+              </a:rPr>
+              <a:t>/</a:t>
             </a:r>
             <a:r>
               <a:rPr sz="2325" b="1">
@@ -11090,7 +11189,18 @@
                 <a:ea typeface="Calibri"/>
                 <a:cs typeface="Calibri"/>
               </a:rPr>
-              <a:t>/Zs</a:t>
+              <a:t>/Z</a:t>
+            </a:r>
+            <a:r>
+              <a:rPr sz="2400" b="1" baseline="-25000">
+                <a:solidFill>
+                  <a:srgbClr val="064F91"/>
+                </a:solidFill>
+                <a:latin typeface="Calibri"/>
+                <a:ea typeface="Calibri"/>
+                <a:cs typeface="Calibri"/>
+              </a:rPr>
+              <a:t>s</a:t>
             </a:r>
           </a:p>
         </p:txBody>
@@ -11191,7 +11301,29 @@
                 <a:ea typeface="Calibri"/>
                 <a:cs typeface="Calibri"/>
               </a:rPr>
-              <a:t> den drivande spänningen och Zs impedansen i hela felslingan.</a:t>
+              <a:t> den drivande spänningen och Z</a:t>
+            </a:r>
+            <a:r>
+              <a:rPr sz="2100" b="0" baseline="-25000">
+                <a:solidFill>
+                  <a:srgbClr val="111111"/>
+                </a:solidFill>
+                <a:latin typeface="Calibri"/>
+                <a:ea typeface="Calibri"/>
+                <a:cs typeface="Calibri"/>
+              </a:rPr>
+              <a:t>s</a:t>
+            </a:r>
+            <a:r>
+              <a:rPr sz="2100" b="0">
+                <a:solidFill>
+                  <a:srgbClr val="111111"/>
+                </a:solidFill>
+                <a:latin typeface="Calibri"/>
+                <a:ea typeface="Calibri"/>
+                <a:cs typeface="Calibri"/>
+              </a:rPr>
+              <a:t> impedansen i hela felslingan.</a:t>
             </a:r>
           </a:p>
         </p:txBody>
@@ -11270,7 +11402,29 @@
                 <a:ea typeface="Calibri"/>
                 <a:cs typeface="Calibri"/>
               </a:rPr>
-              <a:t> = 230 V och Zs = 0,46 Ω.</a:t>
+              <a:t> = 230 V och Z</a:t>
+            </a:r>
+            <a:r>
+              <a:rPr sz="2025" b="0" baseline="-25000">
+                <a:solidFill>
+                  <a:srgbClr val="111111"/>
+                </a:solidFill>
+                <a:latin typeface="Calibri"/>
+                <a:ea typeface="Calibri"/>
+                <a:cs typeface="Calibri"/>
+              </a:rPr>
+              <a:t>s</a:t>
+            </a:r>
+            <a:r>
+              <a:rPr sz="2025" b="0">
+                <a:solidFill>
+                  <a:srgbClr val="111111"/>
+                </a:solidFill>
+                <a:latin typeface="Calibri"/>
+                <a:ea typeface="Calibri"/>
+                <a:cs typeface="Calibri"/>
+              </a:rPr>
+              <a:t> = 0,46 Ω.</a:t>
             </a:r>
           </a:p>
         </p:txBody>
@@ -11626,7 +11780,29 @@
                 <a:ea typeface="Calibri"/>
                 <a:cs typeface="Calibri"/>
               </a:rPr>
-              <a:t> = 230 V och Zs = 0,46 Ω. Beräkna I</a:t>
+              <a:t> = 230 V och Z</a:t>
+            </a:r>
+            <a:r>
+              <a:rPr sz="2400" b="0" baseline="-25000">
+                <a:solidFill>
+                  <a:srgbClr val="111111"/>
+                </a:solidFill>
+                <a:latin typeface="Calibri"/>
+                <a:ea typeface="Calibri"/>
+                <a:cs typeface="Calibri"/>
+              </a:rPr>
+              <a:t>s</a:t>
+            </a:r>
+            <a:r>
+              <a:rPr sz="2400" b="0">
+                <a:solidFill>
+                  <a:srgbClr val="111111"/>
+                </a:solidFill>
+                <a:latin typeface="Calibri"/>
+                <a:ea typeface="Calibri"/>
+                <a:cs typeface="Calibri"/>
+              </a:rPr>
+              <a:t> = 0,46 Ω. Beräkna I</a:t>
             </a:r>
             <a:r>
               <a:rPr sz="2400" b="0" baseline="-25000">
@@ -11992,7 +12168,7 @@
                 <a:ea typeface="Calibri"/>
                 <a:cs typeface="Calibri"/>
               </a:rPr>
-              <a:t>/Zs</a:t>
+              <a:t>/Z</a:t>
             </a:r>
             <a:r>
               <a:rPr sz="2400" b="1" baseline="-25000">
@@ -12003,7 +12179,7 @@
                 <a:ea typeface="Calibri"/>
                 <a:cs typeface="Calibri"/>
               </a:rPr>
-              <a:t>1</a:t>
+              <a:t>s,1</a:t>
             </a:r>
             <a:r>
               <a:rPr sz="2400" b="1">
@@ -12058,7 +12234,7 @@
                 <a:ea typeface="Calibri"/>
                 <a:cs typeface="Calibri"/>
               </a:rPr>
-              <a:t>/Zs</a:t>
+              <a:t>/Z</a:t>
             </a:r>
             <a:r>
               <a:rPr sz="2400" b="1" baseline="-25000">
@@ -12069,7 +12245,7 @@
                 <a:ea typeface="Calibri"/>
                 <a:cs typeface="Calibri"/>
               </a:rPr>
-              <a:t>2</a:t>
+              <a:t>s,2</a:t>
             </a:r>
           </a:p>
         </p:txBody>
@@ -12126,7 +12302,7 @@
                 <a:ea typeface="Calibri"/>
                 <a:cs typeface="Calibri"/>
               </a:rPr>
-              <a:t>1 och 2 står för de två fallen. Vid samma U</a:t>
+              <a:t>1 och 2 står för de två fallen, före och efter ändringen. U</a:t>
             </a:r>
             <a:r>
               <a:rPr sz="2100" b="0" baseline="-25000">
@@ -12148,7 +12324,7 @@
                 <a:ea typeface="Calibri"/>
                 <a:cs typeface="Calibri"/>
               </a:rPr>
-              <a:t> blir strömmen hälften så stor när Zs blir dubbelt så stor.</a:t>
+              <a:t> är samma i båda fallen.</a:t>
             </a:r>
           </a:p>
         </p:txBody>
@@ -12205,7 +12381,40 @@
                 <a:ea typeface="Calibri"/>
                 <a:cs typeface="Calibri"/>
               </a:rPr>
-              <a:t>Förutsättningar: U₀ = 230 V. Impedansen ökar från 0,46 till 0,92 Ω.</a:t>
+              <a:t>Förutsättningar: </a:t>
+            </a:r>
+            <a:r>
+              <a:rPr sz="2025" b="0">
+                <a:solidFill>
+                  <a:srgbClr val="111111"/>
+                </a:solidFill>
+                <a:latin typeface="Calibri"/>
+                <a:ea typeface="Calibri"/>
+                <a:cs typeface="Calibri"/>
+              </a:rPr>
+              <a:t>U</a:t>
+            </a:r>
+            <a:r>
+              <a:rPr sz="2025" b="0" baseline="-25000">
+                <a:solidFill>
+                  <a:srgbClr val="111111"/>
+                </a:solidFill>
+                <a:latin typeface="Calibri"/>
+                <a:ea typeface="Calibri"/>
+                <a:cs typeface="Calibri"/>
+              </a:rPr>
+              <a:t>0</a:t>
+            </a:r>
+            <a:r>
+              <a:rPr sz="2025" b="0">
+                <a:solidFill>
+                  <a:srgbClr val="111111"/>
+                </a:solidFill>
+                <a:latin typeface="Calibri"/>
+                <a:ea typeface="Calibri"/>
+                <a:cs typeface="Calibri"/>
+              </a:rPr>
+              <a:t> = 230 V. Impedansen ökar från 0,46 till 0,92 Ω.</a:t>
             </a:r>
           </a:p>
         </p:txBody>
@@ -13053,7 +13262,29 @@
                 <a:ea typeface="Calibri"/>
                 <a:cs typeface="Calibri"/>
               </a:rPr>
-              <a:t>Zs ökar från 0,46 till 0,92 Ω vid oförändrade 230 V. Hur ändras felströmmen?</a:t>
+              <a:t>Z</a:t>
+            </a:r>
+            <a:r>
+              <a:rPr sz="2400" b="0" baseline="-25000">
+                <a:solidFill>
+                  <a:srgbClr val="111111"/>
+                </a:solidFill>
+                <a:latin typeface="Calibri"/>
+                <a:ea typeface="Calibri"/>
+                <a:cs typeface="Calibri"/>
+              </a:rPr>
+              <a:t>s</a:t>
+            </a:r>
+            <a:r>
+              <a:rPr sz="2400" b="0">
+                <a:solidFill>
+                  <a:srgbClr val="111111"/>
+                </a:solidFill>
+                <a:latin typeface="Calibri"/>
+                <a:ea typeface="Calibri"/>
+                <a:cs typeface="Calibri"/>
+              </a:rPr>
+              <a:t> ökar från 0,46 till 0,92 Ω vid oförändrade 230 V. Hur ändras felströmmen?</a:t>
             </a:r>
           </a:p>
         </p:txBody>
@@ -13386,7 +13617,7 @@
                 <a:ea typeface="Calibri"/>
                 <a:cs typeface="Calibri"/>
               </a:rPr>
-              <a:t>Hur snabbt ett överströmsskydd löser beror på strömmen och skyddets ström–tidkurva.</a:t>
+              <a:t>Ett skydd löser snabbare när strömmen är stor. Hur snabbt står i skyddets ström–tidskurva, ett diagram från tillverkaren.</a:t>
             </a:r>
           </a:p>
         </p:txBody>
@@ -13777,7 +14008,7 @@
                 <a:ea typeface="Calibri"/>
                 <a:cs typeface="Calibri"/>
               </a:rPr>
-              <a:t>Med normal matning kan felströmmen bli 1 000 A, men vid reservdrift bara 200 A. Vad behöver kontrolleras när skydden planeras?</a:t>
+              <a:t>Vid ett fel blir strömmen 1 000 A med vanlig matning. På reservkraft blir den bara 200 A. Vad måste du kontrollera hos skyddet?</a:t>
             </a:r>
           </a:p>
         </p:txBody>
@@ -14224,7 +14455,7 @@
                 <a:ea typeface="Calibri"/>
                 <a:cs typeface="Calibri"/>
               </a:rPr>
-              <a:t>Arbetsgång: Ta reda på vilka nödlaster som finns, hur de reservmatas och vilka fel som kan slå ut både ordinarie utrustning och nödutrustning samtidigt.</a:t>
+              <a:t>Arbetsgång: Tänk på vad som händer med nödutrustningen om just den här fördelningen slutar fungera.</a:t>
             </a:r>
           </a:p>
         </p:txBody>
@@ -14501,7 +14732,7 @@
                 <a:ea typeface="Calibri"/>
                 <a:cs typeface="Calibri"/>
               </a:rPr>
-              <a:t>En enda fördelning matar både ordinarie utrustning och nödutrustning. Vilken fråga måste dokumentationen svara på innan systemet kan bedömas?</a:t>
+              <a:t>Samma fördelning matar både vanlig utrustning och nödutrustning. Vad måste du ta reda på i ritningar och dokument innan du kan säga om det är säkert?</a:t>
             </a:r>
           </a:p>
         </p:txBody>

</xml_diff>